<commit_message>
Update board screenshot in Sprint 4 slides
</commit_message>
<xml_diff>
--- a/Sprints/Sprint_4/Sprint 4 Presentation.pptx
+++ b/Sprints/Sprint_4/Sprint 4 Presentation.pptx
@@ -1069,7 +1069,7 @@
           <a:p/>
           <a:p>
             <a:r>
-              <a:t>Show the board filtered to Sprint 4 and 5. Point out the Done column and that the two remaining items are the deck itself and the C# evaluation moved to Sprint 5. Then briefly say what each person contributed.</a:t>
+              <a:t>Show the board filtered to Sprint 4 and 5. Point out the Done column and that the only open item is the C# evaluation, which moved to Sprint 5. Then briefly say what each person contributed.</a:t>
             </a:r>
           </a:p>
         </p:txBody>
@@ -8888,7 +8888,7 @@
                 </a:solidFill>
                 <a:latin typeface="Calibri"/>
               </a:rPr>
-              <a:t>11 of 12 Sprint 4 issues closed. Each issue has an owner, a story point label, and a comment splitting the points.</a:t>
+              <a:t>All 11 Sprint 4 issues are closed and #36 moved to Sprint 5. Each issue has an owner, a story point label, and a comment splitting the points.</a:t>
             </a:r>
           </a:p>
         </p:txBody>

</xml_diff>

<commit_message>
Finish Sprint 4 slides and report
Fill in the AI use slide, add ctypes and Python bridge demo slides,
note that the prototype source is private, and explain the milestone count.
</commit_message>
<xml_diff>
--- a/Sprints/Sprint_4/Sprint 4 Presentation.pptx
+++ b/Sprints/Sprint_4/Sprint 4 Presentation.pptx
@@ -11,6 +11,8 @@
     <p:sldId id="259" r:id="rId11"/>
     <p:sldId id="260" r:id="rId12"/>
     <p:sldId id="261" r:id="rId13"/>
+    <p:sldId id="269" r:id="rId21"/>
+    <p:sldId id="270" r:id="rId22"/>
     <p:sldId id="262" r:id="rId14"/>
     <p:sldId id="263" r:id="rId15"/>
     <p:sldId id="264" r:id="rId16"/>
@@ -596,7 +598,7 @@
           <a:p/>
           <a:p>
             <a:r>
-              <a:t>Placeholder. Fill in once the team has written up its AI usage.</a:t>
+              <a:t>Disclose that Claude was used for prototyping tools, learning the codebase, phrasing, and the slides. Stress that every deliverable was reviewed by the team and the team is accountable for it.</a:t>
             </a:r>
           </a:p>
         </p:txBody>
@@ -825,6 +827,158 @@
           <a:p>
             <a:r>
               <a:t>Recap the three takeaways. Thank Joe, SEL, and the course staff, and invite questions.</a:t>
+            </a:r>
+          </a:p>
+        </p:txBody>
+      </p:sp>
+      <p:sp>
+        <p:nvSpPr>
+          <p:cNvPr id="4" name="Slide Number Placeholder 3"/>
+          <p:cNvSpPr>
+            <a:spLocks noGrp="1"/>
+          </p:cNvSpPr>
+          <p:nvPr>
+            <p:ph type="sldNum" idx="5" sz="quarter"/>
+          </p:nvPr>
+        </p:nvSpPr>
+        <p:spPr/>
+      </p:sp>
+    </p:spTree>
+  </p:cSld>
+  <p:clrMapOvr>
+    <a:masterClrMapping/>
+  </p:clrMapOvr>
+</p:notes>
+</file>
+
+<file path=ppt/notesSlides/notesSlide14.xml><?xml version="1.0" encoding="utf-8"?>
+<p:notes xmlns:a="http://schemas.openxmlformats.org/drawingml/2006/main" xmlns:p="http://schemas.openxmlformats.org/presentationml/2006/main" xmlns:r="http://schemas.openxmlformats.org/officeDocument/2006/relationships">
+  <p:cSld>
+    <p:spTree>
+      <p:nvGrpSpPr>
+        <p:cNvPr id="1" name=""/>
+        <p:cNvGrpSpPr/>
+        <p:nvPr/>
+      </p:nvGrpSpPr>
+      <p:grpSpPr>
+        <a:xfrm>
+          <a:off x="0" y="0"/>
+          <a:ext cx="0" cy="0"/>
+          <a:chOff x="0" y="0"/>
+          <a:chExt cx="0" cy="0"/>
+        </a:xfrm>
+      </p:grpSpPr>
+      <p:sp>
+        <p:nvSpPr>
+          <p:cNvPr id="2" name="Slide Image Placeholder 1"/>
+          <p:cNvSpPr>
+            <a:spLocks noGrp="1"/>
+          </p:cNvSpPr>
+          <p:nvPr>
+            <p:ph type="sldImg" idx="2"/>
+          </p:nvPr>
+        </p:nvSpPr>
+        <p:spPr/>
+      </p:sp>
+      <p:sp>
+        <p:nvSpPr>
+          <p:cNvPr id="3" name="Notes Placeholder 2"/>
+          <p:cNvSpPr>
+            <a:spLocks noGrp="1"/>
+          </p:cNvSpPr>
+          <p:nvPr>
+            <p:ph type="body" idx="3" sz="quarter"/>
+          </p:nvPr>
+        </p:nvSpPr>
+        <p:spPr/>
+        <p:txBody>
+          <a:bodyPr/>
+          <a:lstStyle/>
+          <a:p>
+            <a:r>
+              <a:t>Presenter: Lucas Phillips</a:t>
+            </a:r>
+          </a:p>
+          <a:p/>
+          <a:p>
+            <a:r>
+              <a:t>Follow the ctypes section of Demo_Script.md. Start the fake hub, run demo_ctypes.py with the three ports it prints, and pipe the output through grep -v '^{"type"' to hide Go debug logs.</a:t>
+            </a:r>
+          </a:p>
+        </p:txBody>
+      </p:sp>
+      <p:sp>
+        <p:nvSpPr>
+          <p:cNvPr id="4" name="Slide Number Placeholder 3"/>
+          <p:cNvSpPr>
+            <a:spLocks noGrp="1"/>
+          </p:cNvSpPr>
+          <p:nvPr>
+            <p:ph type="sldNum" idx="5" sz="quarter"/>
+          </p:nvPr>
+        </p:nvSpPr>
+        <p:spPr/>
+      </p:sp>
+    </p:spTree>
+  </p:cSld>
+  <p:clrMapOvr>
+    <a:masterClrMapping/>
+  </p:clrMapOvr>
+</p:notes>
+</file>
+
+<file path=ppt/notesSlides/notesSlide15.xml><?xml version="1.0" encoding="utf-8"?>
+<p:notes xmlns:a="http://schemas.openxmlformats.org/drawingml/2006/main" xmlns:p="http://schemas.openxmlformats.org/presentationml/2006/main" xmlns:r="http://schemas.openxmlformats.org/officeDocument/2006/relationships">
+  <p:cSld>
+    <p:spTree>
+      <p:nvGrpSpPr>
+        <p:cNvPr id="1" name=""/>
+        <p:cNvGrpSpPr/>
+        <p:nvPr/>
+      </p:nvGrpSpPr>
+      <p:grpSpPr>
+        <a:xfrm>
+          <a:off x="0" y="0"/>
+          <a:ext cx="0" cy="0"/>
+          <a:chOff x="0" y="0"/>
+          <a:chExt cx="0" cy="0"/>
+        </a:xfrm>
+      </p:grpSpPr>
+      <p:sp>
+        <p:nvSpPr>
+          <p:cNvPr id="2" name="Slide Image Placeholder 1"/>
+          <p:cNvSpPr>
+            <a:spLocks noGrp="1"/>
+          </p:cNvSpPr>
+          <p:nvPr>
+            <p:ph type="sldImg" idx="2"/>
+          </p:nvPr>
+        </p:nvSpPr>
+        <p:spPr/>
+      </p:sp>
+      <p:sp>
+        <p:nvSpPr>
+          <p:cNvPr id="3" name="Notes Placeholder 2"/>
+          <p:cNvSpPr>
+            <a:spLocks noGrp="1"/>
+          </p:cNvSpPr>
+          <p:nvPr>
+            <p:ph type="body" idx="3" sz="quarter"/>
+          </p:nvPr>
+        </p:nvSpPr>
+        <p:spPr/>
+        <p:txBody>
+          <a:bodyPr/>
+          <a:lstStyle/>
+          <a:p>
+            <a:r>
+              <a:t>Presenter: Lucas Phillips</a:t>
+            </a:r>
+          </a:p>
+          <a:p/>
+          <a:p>
+            <a:r>
+              <a:t>Follow the bridge section of Demo_Script.md. The kill step is the point of the demo: show that the ctypes version would have taken Python down with it.</a:t>
             </a:r>
           </a:p>
         </p:txBody>
@@ -4867,7 +5021,7 @@
                 </a:solidFill>
                 <a:latin typeface="Calibri"/>
               </a:rPr>
-              <a:t>Placeholders to be filled in by the team</a:t>
+              <a:t>How GenAI was used on this sprint, and how we kept it accountable</a:t>
             </a:r>
           </a:p>
         </p:txBody>
@@ -4970,7 +5124,7 @@
                 </a:solidFill>
                 <a:latin typeface="Calibri"/>
               </a:rPr>
-              <a:t>[PLACEHOLDER] Which tools each member used</a:t>
+              <a:t>Tool used: Claude, by the whole team</a:t>
             </a:r>
           </a:p>
           <a:p>
@@ -4988,7 +5142,7 @@
                 </a:solidFill>
                 <a:latin typeface="Calibri"/>
               </a:rPr>
-              <a:t>[PLACEHOLDER] What they were used for (code, docs, research, meeting notes)</a:t>
+              <a:t>Used to build prototyping tools, learn the codebase we are wrapping, clean up phrasing, and create this presentation</a:t>
             </a:r>
           </a:p>
           <a:p>
@@ -5006,7 +5160,7 @@
                 </a:solidFill>
                 <a:latin typeface="Calibri"/>
               </a:rPr>
-              <a:t>[PLACEHOLDER] What improved as a result</a:t>
+              <a:t>Faster onboarding to a large unfamiliar client and faster prototyping</a:t>
             </a:r>
           </a:p>
         </p:txBody>
@@ -5109,7 +5263,7 @@
                 </a:solidFill>
                 <a:latin typeface="Calibri"/>
               </a:rPr>
-              <a:t>[PLACEHOLDER] Errors or limits seen in AI output</a:t>
+              <a:t>AI output can sound sure and still be wrong about unfamiliar code</a:t>
             </a:r>
           </a:p>
           <a:p>
@@ -5127,7 +5281,7 @@
                 </a:solidFill>
                 <a:latin typeface="Calibri"/>
               </a:rPr>
-              <a:t>[PLACEHOLDER] How AI output was checked and corrected</a:t>
+              <a:t>Code was checked against the 2,155 test suite and text was reviewed and edited by the team</a:t>
             </a:r>
           </a:p>
           <a:p>
@@ -5145,7 +5299,7 @@
                 </a:solidFill>
                 <a:latin typeface="Calibri"/>
               </a:rPr>
-              <a:t>[PLACEHOLDER] Confidentiality handling for SEL code</a:t>
+              <a:t>SEL client code stays in the private repo and public docs share results only</a:t>
             </a:r>
           </a:p>
           <a:p>
@@ -6728,6 +6882,2172 @@
 </p:sld>
 </file>
 
+<file path=ppt/slides/slide14.xml><?xml version="1.0" encoding="utf-8"?>
+<p:sld xmlns:a="http://schemas.openxmlformats.org/drawingml/2006/main" xmlns:p="http://schemas.openxmlformats.org/presentationml/2006/main" xmlns:r="http://schemas.openxmlformats.org/officeDocument/2006/relationships">
+  <p:cSld>
+    <p:bg>
+      <p:bgPr>
+        <a:solidFill>
+          <a:srgbClr val="FFFFFF"/>
+        </a:solidFill>
+        <a:effectLst/>
+      </p:bgPr>
+    </p:bg>
+    <p:spTree>
+      <p:nvGrpSpPr>
+        <p:cNvPr id="1" name=""/>
+        <p:cNvGrpSpPr/>
+        <p:nvPr/>
+      </p:nvGrpSpPr>
+      <p:grpSpPr/>
+      <p:sp>
+        <p:nvSpPr>
+          <p:cNvPr id="2" name="Oval 1"/>
+          <p:cNvSpPr/>
+          <p:nvPr/>
+        </p:nvSpPr>
+        <p:spPr>
+          <a:xfrm>
+            <a:off x="548640" y="457200"/>
+            <a:ext cx="566928" cy="566928"/>
+          </a:xfrm>
+          <a:prstGeom prst="ellipse">
+            <a:avLst/>
+          </a:prstGeom>
+          <a:solidFill>
+            <a:srgbClr val="F2A541"/>
+          </a:solidFill>
+          <a:ln>
+            <a:noFill/>
+          </a:ln>
+          <a:effectLst/>
+        </p:spPr>
+        <p:style>
+          <a:lnRef idx="1">
+            <a:schemeClr val="accent1"/>
+          </a:lnRef>
+          <a:fillRef idx="3">
+            <a:schemeClr val="accent1"/>
+          </a:fillRef>
+          <a:effectRef idx="2">
+            <a:schemeClr val="accent1"/>
+          </a:effectRef>
+          <a:fontRef idx="minor">
+            <a:schemeClr val="lt1"/>
+          </a:fontRef>
+        </p:style>
+        <p:txBody>
+          <a:bodyPr rtlCol="0" anchor="ctr" lIns="0" rIns="0" tIns="0" bIns="0"/>
+          <a:lstStyle/>
+          <a:p>
+            <a:pPr algn="ctr"/>
+            <a:r>
+              <a:rPr sz="1800" b="1" i="0">
+                <a:solidFill>
+                  <a:srgbClr val="1B2A41"/>
+                </a:solidFill>
+                <a:latin typeface="Cambria"/>
+              </a:rPr>
+              <a:t>3</a:t>
+            </a:r>
+          </a:p>
+        </p:txBody>
+      </p:sp>
+      <p:sp>
+        <p:nvSpPr>
+          <p:cNvPr id="3" name="TextBox 2"/>
+          <p:cNvSpPr txBox="1"/>
+          <p:nvPr/>
+        </p:nvSpPr>
+        <p:spPr>
+          <a:xfrm>
+            <a:off x="1280160" y="384048"/>
+            <a:ext cx="10332720" cy="731520"/>
+          </a:xfrm>
+          <a:prstGeom prst="rect">
+            <a:avLst/>
+          </a:prstGeom>
+          <a:noFill/>
+        </p:spPr>
+        <p:txBody>
+          <a:bodyPr wrap="square" anchor="ctr" lIns="0" rIns="0" tIns="0" bIns="0">
+            <a:spAutoFit/>
+          </a:bodyPr>
+          <a:lstStyle/>
+          <a:p>
+            <a:pPr algn="l">
+              <a:spcAft>
+                <a:spcPts val="600"/>
+              </a:spcAft>
+            </a:pPr>
+            <a:r>
+              <a:rPr sz="3200" b="1" i="0">
+                <a:solidFill>
+                  <a:srgbClr val="1B2A41"/>
+                </a:solidFill>
+                <a:latin typeface="Cambria"/>
+              </a:rPr>
+              <a:t>Demo: ctypes Transport</a:t>
+            </a:r>
+          </a:p>
+        </p:txBody>
+      </p:sp>
+      <p:sp>
+        <p:nvSpPr>
+          <p:cNvPr id="4" name="TextBox 3"/>
+          <p:cNvSpPr txBox="1"/>
+          <p:nvPr/>
+        </p:nvSpPr>
+        <p:spPr>
+          <a:xfrm>
+            <a:off x="1280160" y="1024128"/>
+            <a:ext cx="10332720" cy="411480"/>
+          </a:xfrm>
+          <a:prstGeom prst="rect">
+            <a:avLst/>
+          </a:prstGeom>
+          <a:noFill/>
+        </p:spPr>
+        <p:txBody>
+          <a:bodyPr wrap="square" anchor="t" lIns="0" rIns="0" tIns="0" bIns="0">
+            <a:spAutoFit/>
+          </a:bodyPr>
+          <a:lstStyle/>
+          <a:p>
+            <a:pPr algn="l">
+              <a:spcAft>
+                <a:spcPts val="600"/>
+              </a:spcAft>
+            </a:pPr>
+            <a:r>
+              <a:rPr sz="1500" b="0" i="1">
+                <a:solidFill>
+                  <a:srgbClr val="5B6B7A"/>
+                </a:solidFill>
+                <a:latin typeface="Calibri"/>
+              </a:rPr>
+              <a:t>Go runs inside the Python process  |  Lucas Phillips</a:t>
+            </a:r>
+          </a:p>
+        </p:txBody>
+      </p:sp>
+      <p:sp>
+        <p:nvSpPr>
+          <p:cNvPr id="5" name="TextBox 4"/>
+          <p:cNvSpPr txBox="1"/>
+          <p:nvPr/>
+        </p:nvSpPr>
+        <p:spPr>
+          <a:xfrm>
+            <a:off x="548640" y="1554480"/>
+            <a:ext cx="5486040" cy="274680"/>
+          </a:xfrm>
+          <a:prstGeom prst="rect">
+            <a:avLst/>
+          </a:prstGeom>
+          <a:noFill/>
+        </p:spPr>
+        <p:txBody>
+          <a:bodyPr wrap="square" lIns="0" rIns="0" tIns="0" bIns="0">
+            <a:spAutoFit/>
+          </a:bodyPr>
+          <a:lstStyle/>
+          <a:p>
+            <a:pPr>
+              <a:spcAft>
+                <a:spcPts val="400"/>
+              </a:spcAft>
+            </a:pPr>
+            <a:r>
+              <a:rPr sz="1800" b="1">
+                <a:solidFill>
+                  <a:srgbClr val="1B2A41"/>
+                </a:solidFill>
+                <a:latin typeface="Cambria"/>
+              </a:rPr>
+              <a:t>What we will show</a:t>
+            </a:r>
+          </a:p>
+        </p:txBody>
+      </p:sp>
+      <p:sp>
+        <p:nvSpPr>
+          <p:cNvPr id="6" name="Rounded Rectangle 5"/>
+          <p:cNvSpPr/>
+          <p:nvPr/>
+        </p:nvSpPr>
+        <p:spPr>
+          <a:xfrm>
+            <a:off x="548640" y="1965960"/>
+            <a:ext cx="5668920" cy="968760"/>
+          </a:xfrm>
+          <a:prstGeom prst="roundRect">
+            <a:avLst>
+              <a:gd name="adj" fmla="val 6000"/>
+            </a:avLst>
+          </a:prstGeom>
+          <a:solidFill>
+            <a:srgbClr val="EEF2F6"/>
+          </a:solidFill>
+          <a:ln>
+            <a:noFill/>
+          </a:ln>
+          <a:effectLst/>
+        </p:spPr>
+        <p:style>
+          <a:lnRef idx="1">
+            <a:schemeClr val="accent1"/>
+          </a:lnRef>
+          <a:fillRef idx="3">
+            <a:schemeClr val="accent1"/>
+          </a:fillRef>
+          <a:effectRef idx="2">
+            <a:schemeClr val="accent1"/>
+          </a:effectRef>
+          <a:fontRef idx="minor">
+            <a:schemeClr val="lt1"/>
+          </a:fontRef>
+        </p:style>
+        <p:txBody>
+          <a:bodyPr rtlCol="0" anchor="ctr"/>
+          <a:lstStyle/>
+          <a:p>
+            <a:pPr algn="ctr"/>
+          </a:p>
+        </p:txBody>
+      </p:sp>
+      <p:sp>
+        <p:nvSpPr>
+          <p:cNvPr id="7" name="Oval 6"/>
+          <p:cNvSpPr/>
+          <p:nvPr/>
+        </p:nvSpPr>
+        <p:spPr>
+          <a:xfrm>
+            <a:off x="731520" y="2265960"/>
+            <a:ext cx="368000" cy="368000"/>
+          </a:xfrm>
+          <a:prstGeom prst="ellipse">
+            <a:avLst/>
+          </a:prstGeom>
+          <a:solidFill>
+            <a:srgbClr val="F2A541"/>
+          </a:solidFill>
+          <a:ln>
+            <a:noFill/>
+          </a:ln>
+          <a:effectLst/>
+        </p:spPr>
+        <p:style>
+          <a:lnRef idx="1">
+            <a:schemeClr val="accent1"/>
+          </a:lnRef>
+          <a:fillRef idx="3">
+            <a:schemeClr val="accent1"/>
+          </a:fillRef>
+          <a:effectRef idx="2">
+            <a:schemeClr val="accent1"/>
+          </a:effectRef>
+          <a:fontRef idx="minor">
+            <a:schemeClr val="lt1"/>
+          </a:fontRef>
+        </p:style>
+        <p:txBody>
+          <a:bodyPr rtlCol="0" anchor="ctr" lIns="0" rIns="0" wrap="square"/>
+          <a:lstStyle/>
+          <a:p>
+            <a:pPr algn="ctr">
+              <a:spcAft>
+                <a:spcPts val="400"/>
+              </a:spcAft>
+            </a:pPr>
+            <a:r>
+              <a:rPr sz="1400" b="1">
+                <a:solidFill>
+                  <a:srgbClr val="1B2A41"/>
+                </a:solidFill>
+                <a:latin typeface="Cambria"/>
+              </a:rPr>
+              <a:t>1</a:t>
+            </a:r>
+          </a:p>
+        </p:txBody>
+      </p:sp>
+      <p:sp>
+        <p:nvSpPr>
+          <p:cNvPr id="8" name="TextBox 7"/>
+          <p:cNvSpPr txBox="1"/>
+          <p:nvPr/>
+        </p:nvSpPr>
+        <p:spPr>
+          <a:xfrm>
+            <a:off x="1280160" y="2115960"/>
+            <a:ext cx="4800000" cy="700000"/>
+          </a:xfrm>
+          <a:prstGeom prst="rect">
+            <a:avLst/>
+          </a:prstGeom>
+          <a:noFill/>
+        </p:spPr>
+        <p:txBody>
+          <a:bodyPr wrap="square" lIns="0" rIns="0" tIns="0" bIns="0">
+            <a:spAutoFit/>
+          </a:bodyPr>
+          <a:lstStyle/>
+          <a:p>
+            <a:pPr>
+              <a:spcAft>
+                <a:spcPts val="400"/>
+              </a:spcAft>
+            </a:pPr>
+            <a:r>
+              <a:rPr sz="1500" b="1">
+                <a:solidFill>
+                  <a:srgbClr val="1B2A41"/>
+                </a:solidFill>
+                <a:latin typeface="Cambria"/>
+              </a:rPr>
+              <a:t>Go library loads into Python</a:t>
+            </a:r>
+          </a:p>
+        </p:txBody>
+      </p:sp>
+      <p:sp>
+        <p:nvSpPr>
+          <p:cNvPr id="9" name="TextBox 8"/>
+          <p:cNvSpPr txBox="1"/>
+          <p:nvPr/>
+        </p:nvSpPr>
+        <p:spPr>
+          <a:xfrm>
+            <a:off x="1280160" y="2435960"/>
+            <a:ext cx="4800000" cy="450000"/>
+          </a:xfrm>
+          <a:prstGeom prst="rect">
+            <a:avLst/>
+          </a:prstGeom>
+          <a:noFill/>
+        </p:spPr>
+        <p:txBody>
+          <a:bodyPr wrap="square" lIns="0" rIns="0" tIns="0" bIns="0">
+            <a:spAutoFit/>
+          </a:bodyPr>
+          <a:lstStyle/>
+          <a:p>
+            <a:pPr>
+              <a:spcAft>
+                <a:spcPts val="400"/>
+              </a:spcAft>
+            </a:pPr>
+            <a:r>
+              <a:rPr sz="1200" b="0">
+                <a:solidFill>
+                  <a:srgbClr val="1F2933"/>
+                </a:solidFill>
+                <a:latin typeface="Calibri"/>
+              </a:rPr>
+              <a:t>libgosignals.so is mapped into our process and there are no child processes</a:t>
+            </a:r>
+          </a:p>
+        </p:txBody>
+      </p:sp>
+      <p:sp>
+        <p:nvSpPr>
+          <p:cNvPr id="10" name="Rounded Rectangle 9"/>
+          <p:cNvSpPr/>
+          <p:nvPr/>
+        </p:nvSpPr>
+        <p:spPr>
+          <a:xfrm>
+            <a:off x="548640" y="3045240"/>
+            <a:ext cx="5668920" cy="968760"/>
+          </a:xfrm>
+          <a:prstGeom prst="roundRect">
+            <a:avLst>
+              <a:gd name="adj" fmla="val 6000"/>
+            </a:avLst>
+          </a:prstGeom>
+          <a:solidFill>
+            <a:srgbClr val="EEF2F6"/>
+          </a:solidFill>
+          <a:ln>
+            <a:noFill/>
+          </a:ln>
+          <a:effectLst/>
+        </p:spPr>
+        <p:style>
+          <a:lnRef idx="1">
+            <a:schemeClr val="accent1"/>
+          </a:lnRef>
+          <a:fillRef idx="3">
+            <a:schemeClr val="accent1"/>
+          </a:fillRef>
+          <a:effectRef idx="2">
+            <a:schemeClr val="accent1"/>
+          </a:effectRef>
+          <a:fontRef idx="minor">
+            <a:schemeClr val="lt1"/>
+          </a:fontRef>
+        </p:style>
+        <p:txBody>
+          <a:bodyPr rtlCol="0" anchor="ctr"/>
+          <a:lstStyle/>
+          <a:p>
+            <a:pPr algn="ctr"/>
+          </a:p>
+        </p:txBody>
+      </p:sp>
+      <p:sp>
+        <p:nvSpPr>
+          <p:cNvPr id="11" name="Oval 10"/>
+          <p:cNvSpPr/>
+          <p:nvPr/>
+        </p:nvSpPr>
+        <p:spPr>
+          <a:xfrm>
+            <a:off x="731520" y="3345240"/>
+            <a:ext cx="368000" cy="368000"/>
+          </a:xfrm>
+          <a:prstGeom prst="ellipse">
+            <a:avLst/>
+          </a:prstGeom>
+          <a:solidFill>
+            <a:srgbClr val="F2A541"/>
+          </a:solidFill>
+          <a:ln>
+            <a:noFill/>
+          </a:ln>
+          <a:effectLst/>
+        </p:spPr>
+        <p:style>
+          <a:lnRef idx="1">
+            <a:schemeClr val="accent1"/>
+          </a:lnRef>
+          <a:fillRef idx="3">
+            <a:schemeClr val="accent1"/>
+          </a:fillRef>
+          <a:effectRef idx="2">
+            <a:schemeClr val="accent1"/>
+          </a:effectRef>
+          <a:fontRef idx="minor">
+            <a:schemeClr val="lt1"/>
+          </a:fontRef>
+        </p:style>
+        <p:txBody>
+          <a:bodyPr rtlCol="0" anchor="ctr" lIns="0" rIns="0" wrap="square"/>
+          <a:lstStyle/>
+          <a:p>
+            <a:pPr algn="ctr">
+              <a:spcAft>
+                <a:spcPts val="400"/>
+              </a:spcAft>
+            </a:pPr>
+            <a:r>
+              <a:rPr sz="1400" b="1">
+                <a:solidFill>
+                  <a:srgbClr val="1B2A41"/>
+                </a:solidFill>
+                <a:latin typeface="Cambria"/>
+              </a:rPr>
+              <a:t>2</a:t>
+            </a:r>
+          </a:p>
+        </p:txBody>
+      </p:sp>
+      <p:sp>
+        <p:nvSpPr>
+          <p:cNvPr id="12" name="TextBox 11"/>
+          <p:cNvSpPr txBox="1"/>
+          <p:nvPr/>
+        </p:nvSpPr>
+        <p:spPr>
+          <a:xfrm>
+            <a:off x="1280160" y="3195240"/>
+            <a:ext cx="4800000" cy="700000"/>
+          </a:xfrm>
+          <a:prstGeom prst="rect">
+            <a:avLst/>
+          </a:prstGeom>
+          <a:noFill/>
+        </p:spPr>
+        <p:txBody>
+          <a:bodyPr wrap="square" lIns="0" rIns="0" tIns="0" bIns="0">
+            <a:spAutoFit/>
+          </a:bodyPr>
+          <a:lstStyle/>
+          <a:p>
+            <a:pPr>
+              <a:spcAft>
+                <a:spcPts val="400"/>
+              </a:spcAft>
+            </a:pPr>
+            <a:r>
+              <a:rPr sz="1500" b="1">
+                <a:solidFill>
+                  <a:srgbClr val="1B2A41"/>
+                </a:solidFill>
+                <a:latin typeface="Cambria"/>
+              </a:rPr>
+              <a:t>Publish and fetch with numpy</a:t>
+            </a:r>
+          </a:p>
+        </p:txBody>
+      </p:sp>
+      <p:sp>
+        <p:nvSpPr>
+          <p:cNvPr id="13" name="TextBox 12"/>
+          <p:cNvSpPr txBox="1"/>
+          <p:nvPr/>
+        </p:nvSpPr>
+        <p:spPr>
+          <a:xfrm>
+            <a:off x="1280160" y="3515240"/>
+            <a:ext cx="4800000" cy="450000"/>
+          </a:xfrm>
+          <a:prstGeom prst="rect">
+            <a:avLst/>
+          </a:prstGeom>
+          <a:noFill/>
+        </p:spPr>
+        <p:txBody>
+          <a:bodyPr wrap="square" lIns="0" rIns="0" tIns="0" bIns="0">
+            <a:spAutoFit/>
+          </a:bodyPr>
+          <a:lstStyle/>
+          <a:p>
+            <a:pPr>
+              <a:spcAft>
+                <a:spcPts val="400"/>
+              </a:spcAft>
+            </a:pPr>
+            <a:r>
+              <a:rPr sz="1200" b="0">
+                <a:solidFill>
+                  <a:srgbClr val="1F2933"/>
+                </a:solidFill>
+                <a:latin typeface="Calibri"/>
+              </a:rPr>
+              <a:t>Two phases published, history fetched back as a numpy array</a:t>
+            </a:r>
+          </a:p>
+        </p:txBody>
+      </p:sp>
+      <p:sp>
+        <p:nvSpPr>
+          <p:cNvPr id="14" name="Rounded Rectangle 13"/>
+          <p:cNvSpPr/>
+          <p:nvPr/>
+        </p:nvSpPr>
+        <p:spPr>
+          <a:xfrm>
+            <a:off x="548640" y="4124520"/>
+            <a:ext cx="5668920" cy="968760"/>
+          </a:xfrm>
+          <a:prstGeom prst="roundRect">
+            <a:avLst>
+              <a:gd name="adj" fmla="val 6000"/>
+            </a:avLst>
+          </a:prstGeom>
+          <a:solidFill>
+            <a:srgbClr val="EEF2F6"/>
+          </a:solidFill>
+          <a:ln>
+            <a:noFill/>
+          </a:ln>
+          <a:effectLst/>
+        </p:spPr>
+        <p:style>
+          <a:lnRef idx="1">
+            <a:schemeClr val="accent1"/>
+          </a:lnRef>
+          <a:fillRef idx="3">
+            <a:schemeClr val="accent1"/>
+          </a:fillRef>
+          <a:effectRef idx="2">
+            <a:schemeClr val="accent1"/>
+          </a:effectRef>
+          <a:fontRef idx="minor">
+            <a:schemeClr val="lt1"/>
+          </a:fontRef>
+        </p:style>
+        <p:txBody>
+          <a:bodyPr rtlCol="0" anchor="ctr"/>
+          <a:lstStyle/>
+          <a:p>
+            <a:pPr algn="ctr"/>
+          </a:p>
+        </p:txBody>
+      </p:sp>
+      <p:sp>
+        <p:nvSpPr>
+          <p:cNvPr id="15" name="Oval 14"/>
+          <p:cNvSpPr/>
+          <p:nvPr/>
+        </p:nvSpPr>
+        <p:spPr>
+          <a:xfrm>
+            <a:off x="731520" y="4424520"/>
+            <a:ext cx="368000" cy="368000"/>
+          </a:xfrm>
+          <a:prstGeom prst="ellipse">
+            <a:avLst/>
+          </a:prstGeom>
+          <a:solidFill>
+            <a:srgbClr val="F2A541"/>
+          </a:solidFill>
+          <a:ln>
+            <a:noFill/>
+          </a:ln>
+          <a:effectLst/>
+        </p:spPr>
+        <p:style>
+          <a:lnRef idx="1">
+            <a:schemeClr val="accent1"/>
+          </a:lnRef>
+          <a:fillRef idx="3">
+            <a:schemeClr val="accent1"/>
+          </a:fillRef>
+          <a:effectRef idx="2">
+            <a:schemeClr val="accent1"/>
+          </a:effectRef>
+          <a:fontRef idx="minor">
+            <a:schemeClr val="lt1"/>
+          </a:fontRef>
+        </p:style>
+        <p:txBody>
+          <a:bodyPr rtlCol="0" anchor="ctr" lIns="0" rIns="0" wrap="square"/>
+          <a:lstStyle/>
+          <a:p>
+            <a:pPr algn="ctr">
+              <a:spcAft>
+                <a:spcPts val="400"/>
+              </a:spcAft>
+            </a:pPr>
+            <a:r>
+              <a:rPr sz="1400" b="1">
+                <a:solidFill>
+                  <a:srgbClr val="1B2A41"/>
+                </a:solidFill>
+                <a:latin typeface="Cambria"/>
+              </a:rPr>
+              <a:t>3</a:t>
+            </a:r>
+          </a:p>
+        </p:txBody>
+      </p:sp>
+      <p:sp>
+        <p:nvSpPr>
+          <p:cNvPr id="16" name="TextBox 15"/>
+          <p:cNvSpPr txBox="1"/>
+          <p:nvPr/>
+        </p:nvSpPr>
+        <p:spPr>
+          <a:xfrm>
+            <a:off x="1280160" y="4274520"/>
+            <a:ext cx="4800000" cy="700000"/>
+          </a:xfrm>
+          <a:prstGeom prst="rect">
+            <a:avLst/>
+          </a:prstGeom>
+          <a:noFill/>
+        </p:spPr>
+        <p:txBody>
+          <a:bodyPr wrap="square" lIns="0" rIns="0" tIns="0" bIns="0">
+            <a:spAutoFit/>
+          </a:bodyPr>
+          <a:lstStyle/>
+          <a:p>
+            <a:pPr>
+              <a:spcAft>
+                <a:spcPts val="400"/>
+              </a:spcAft>
+            </a:pPr>
+            <a:r>
+              <a:rPr sz="1500" b="1">
+                <a:solidFill>
+                  <a:srgbClr val="1B2A41"/>
+                </a:solidFill>
+                <a:latin typeface="Cambria"/>
+              </a:rPr>
+              <a:t>Aligned view and bad input</a:t>
+            </a:r>
+          </a:p>
+        </p:txBody>
+      </p:sp>
+      <p:sp>
+        <p:nvSpPr>
+          <p:cNvPr id="17" name="TextBox 16"/>
+          <p:cNvSpPr txBox="1"/>
+          <p:nvPr/>
+        </p:nvSpPr>
+        <p:spPr>
+          <a:xfrm>
+            <a:off x="1280160" y="4594520"/>
+            <a:ext cx="4800000" cy="450000"/>
+          </a:xfrm>
+          <a:prstGeom prst="rect">
+            <a:avLst/>
+          </a:prstGeom>
+          <a:noFill/>
+        </p:spPr>
+        <p:txBody>
+          <a:bodyPr wrap="square" lIns="0" rIns="0" tIns="0" bIns="0">
+            <a:spAutoFit/>
+          </a:bodyPr>
+          <a:lstStyle/>
+          <a:p>
+            <a:pPr>
+              <a:spcAft>
+                <a:spcPts val="400"/>
+              </a:spcAft>
+            </a:pPr>
+            <a:r>
+              <a:rPr sz="1200" b="0">
+                <a:solidFill>
+                  <a:srgbClr val="1F2933"/>
+                </a:solidFill>
+                <a:latin typeface="Calibri"/>
+              </a:rPr>
+              <a:t>Both phases read on one time grid, and bad input gives a Python exception</a:t>
+            </a:r>
+          </a:p>
+        </p:txBody>
+      </p:sp>
+      <p:sp>
+        <p:nvSpPr>
+          <p:cNvPr id="18" name="TextBox 17"/>
+          <p:cNvSpPr txBox="1"/>
+          <p:nvPr/>
+        </p:nvSpPr>
+        <p:spPr>
+          <a:xfrm>
+            <a:off x="6492240" y="1554480"/>
+            <a:ext cx="5166000" cy="274680"/>
+          </a:xfrm>
+          <a:prstGeom prst="rect">
+            <a:avLst/>
+          </a:prstGeom>
+          <a:noFill/>
+        </p:spPr>
+        <p:txBody>
+          <a:bodyPr wrap="square" lIns="0" rIns="0" tIns="0" bIns="0">
+            <a:spAutoFit/>
+          </a:bodyPr>
+          <a:lstStyle/>
+          <a:p>
+            <a:pPr>
+              <a:spcAft>
+                <a:spcPts val="400"/>
+              </a:spcAft>
+            </a:pPr>
+            <a:r>
+              <a:rPr sz="1800" b="1">
+                <a:solidFill>
+                  <a:srgbClr val="1B2A41"/>
+                </a:solidFill>
+                <a:latin typeface="Cambria"/>
+              </a:rPr>
+              <a:t>Run it</a:t>
+            </a:r>
+          </a:p>
+        </p:txBody>
+      </p:sp>
+      <p:sp>
+        <p:nvSpPr>
+          <p:cNvPr id="19" name="Rounded Rectangle 18"/>
+          <p:cNvSpPr/>
+          <p:nvPr/>
+        </p:nvSpPr>
+        <p:spPr>
+          <a:xfrm>
+            <a:off x="6492240" y="1965960"/>
+            <a:ext cx="5166000" cy="1750000"/>
+          </a:xfrm>
+          <a:prstGeom prst="roundRect">
+            <a:avLst>
+              <a:gd name="adj" fmla="val 6000"/>
+            </a:avLst>
+          </a:prstGeom>
+          <a:solidFill>
+            <a:srgbClr val="1B2A41"/>
+          </a:solidFill>
+          <a:ln>
+            <a:noFill/>
+          </a:ln>
+          <a:effectLst/>
+        </p:spPr>
+        <p:style>
+          <a:lnRef idx="1">
+            <a:schemeClr val="accent1"/>
+          </a:lnRef>
+          <a:fillRef idx="3">
+            <a:schemeClr val="accent1"/>
+          </a:fillRef>
+          <a:effectRef idx="2">
+            <a:schemeClr val="accent1"/>
+          </a:effectRef>
+          <a:fontRef idx="minor">
+            <a:schemeClr val="lt1"/>
+          </a:fontRef>
+        </p:style>
+        <p:txBody>
+          <a:bodyPr rtlCol="0" anchor="ctr"/>
+          <a:lstStyle/>
+          <a:p>
+            <a:pPr algn="ctr"/>
+          </a:p>
+        </p:txBody>
+      </p:sp>
+      <p:sp>
+        <p:nvSpPr>
+          <p:cNvPr id="20" name="TextBox 19"/>
+          <p:cNvSpPr txBox="1"/>
+          <p:nvPr/>
+        </p:nvSpPr>
+        <p:spPr>
+          <a:xfrm>
+            <a:off x="6675120" y="2100000"/>
+            <a:ext cx="4800000" cy="1500000"/>
+          </a:xfrm>
+          <a:prstGeom prst="rect">
+            <a:avLst/>
+          </a:prstGeom>
+          <a:noFill/>
+        </p:spPr>
+        <p:txBody>
+          <a:bodyPr wrap="square" lIns="0" rIns="0" tIns="0" bIns="0">
+            <a:spAutoFit/>
+          </a:bodyPr>
+          <a:lstStyle/>
+          <a:p>
+            <a:pPr>
+              <a:spcAft>
+                <a:spcPts val="400"/>
+              </a:spcAft>
+            </a:pPr>
+            <a:r>
+              <a:rPr sz="1200" b="0">
+                <a:solidFill>
+                  <a:srgbClr val="E8EEF4"/>
+                </a:solidFill>
+                <a:latin typeface="Consolas"/>
+              </a:rPr>
+              <a:t># 1. start the fake Signal Hub (prints 3 ports)</a:t>
+            </a:r>
+          </a:p>
+          <a:p>
+            <a:pPr>
+              <a:spcAft>
+                <a:spcPts val="400"/>
+              </a:spcAft>
+            </a:pPr>
+            <a:r>
+              <a:rPr sz="1200" b="0">
+                <a:solidFill>
+                  <a:srgbClr val="E8EEF4"/>
+                </a:solidFill>
+                <a:latin typeface="Consolas"/>
+              </a:rPr>
+              <a:t>./build/testhub</a:t>
+            </a:r>
+          </a:p>
+          <a:p>
+            <a:pPr>
+              <a:spcAft>
+                <a:spcPts val="400"/>
+              </a:spcAft>
+            </a:pPr>
+            <a:r>
+              <a:rPr sz="1200" b="0">
+                <a:solidFill>
+                  <a:srgbClr val="E8EEF4"/>
+                </a:solidFill>
+                <a:latin typeface="Consolas"/>
+              </a:rPr>
+              <a:t/>
+            </a:r>
+          </a:p>
+          <a:p>
+            <a:pPr>
+              <a:spcAft>
+                <a:spcPts val="400"/>
+              </a:spcAft>
+            </a:pPr>
+            <a:r>
+              <a:rPr sz="1200" b="0">
+                <a:solidFill>
+                  <a:srgbClr val="E8EEF4"/>
+                </a:solidFill>
+                <a:latin typeface="Consolas"/>
+              </a:rPr>
+              <a:t># 2. run the demo with those ports</a:t>
+            </a:r>
+          </a:p>
+          <a:p>
+            <a:pPr>
+              <a:spcAft>
+                <a:spcPts val="400"/>
+              </a:spcAft>
+            </a:pPr>
+            <a:r>
+              <a:rPr sz="1200" b="0">
+                <a:solidFill>
+                  <a:srgbClr val="E8EEF4"/>
+                </a:solidFill>
+                <a:latin typeface="Consolas"/>
+              </a:rPr>
+              <a:t>python examples/demo_ctypes.py HUB GRAPH NATS</a:t>
+            </a:r>
+          </a:p>
+        </p:txBody>
+      </p:sp>
+      <p:sp>
+        <p:nvSpPr>
+          <p:cNvPr id="21" name="TextBox 20"/>
+          <p:cNvSpPr txBox="1"/>
+          <p:nvPr/>
+        </p:nvSpPr>
+        <p:spPr>
+          <a:xfrm>
+            <a:off x="6492240" y="3900000"/>
+            <a:ext cx="5166000" cy="274680"/>
+          </a:xfrm>
+          <a:prstGeom prst="rect">
+            <a:avLst/>
+          </a:prstGeom>
+          <a:noFill/>
+        </p:spPr>
+        <p:txBody>
+          <a:bodyPr wrap="square" lIns="0" rIns="0" tIns="0" bIns="0">
+            <a:spAutoFit/>
+          </a:bodyPr>
+          <a:lstStyle/>
+          <a:p>
+            <a:pPr>
+              <a:spcAft>
+                <a:spcPts val="400"/>
+              </a:spcAft>
+            </a:pPr>
+            <a:r>
+              <a:rPr sz="1800" b="1">
+                <a:solidFill>
+                  <a:srgbClr val="1B2A41"/>
+                </a:solidFill>
+                <a:latin typeface="Cambria"/>
+              </a:rPr>
+              <a:t>Point out</a:t>
+            </a:r>
+          </a:p>
+        </p:txBody>
+      </p:sp>
+      <p:sp>
+        <p:nvSpPr>
+          <p:cNvPr id="22" name="Rounded Rectangle 21"/>
+          <p:cNvSpPr/>
+          <p:nvPr/>
+        </p:nvSpPr>
+        <p:spPr>
+          <a:xfrm>
+            <a:off x="6492240" y="4300000"/>
+            <a:ext cx="5166000" cy="1960000"/>
+          </a:xfrm>
+          <a:prstGeom prst="roundRect">
+            <a:avLst>
+              <a:gd name="adj" fmla="val 6000"/>
+            </a:avLst>
+          </a:prstGeom>
+          <a:solidFill>
+            <a:srgbClr val="EEF2F6"/>
+          </a:solidFill>
+          <a:ln>
+            <a:noFill/>
+          </a:ln>
+          <a:effectLst/>
+        </p:spPr>
+        <p:style>
+          <a:lnRef idx="1">
+            <a:schemeClr val="accent1"/>
+          </a:lnRef>
+          <a:fillRef idx="3">
+            <a:schemeClr val="accent1"/>
+          </a:fillRef>
+          <a:effectRef idx="2">
+            <a:schemeClr val="accent1"/>
+          </a:effectRef>
+          <a:fontRef idx="minor">
+            <a:schemeClr val="lt1"/>
+          </a:fontRef>
+        </p:style>
+        <p:txBody>
+          <a:bodyPr rtlCol="0" anchor="ctr"/>
+          <a:lstStyle/>
+          <a:p>
+            <a:pPr algn="ctr"/>
+          </a:p>
+        </p:txBody>
+      </p:sp>
+      <p:sp>
+        <p:nvSpPr>
+          <p:cNvPr id="23" name="TextBox 22"/>
+          <p:cNvSpPr txBox="1"/>
+          <p:nvPr/>
+        </p:nvSpPr>
+        <p:spPr>
+          <a:xfrm>
+            <a:off x="6675120" y="4420000"/>
+            <a:ext cx="4800000" cy="1750000"/>
+          </a:xfrm>
+          <a:prstGeom prst="rect">
+            <a:avLst/>
+          </a:prstGeom>
+          <a:noFill/>
+        </p:spPr>
+        <p:txBody>
+          <a:bodyPr wrap="square" lIns="0" rIns="0" tIns="0" bIns="0">
+            <a:spAutoFit/>
+          </a:bodyPr>
+          <a:lstStyle/>
+          <a:p>
+            <a:pPr>
+              <a:spcAft>
+                <a:spcPts val="400"/>
+              </a:spcAft>
+            </a:pPr>
+            <a:r>
+              <a:rPr sz="1300" b="0">
+                <a:solidFill>
+                  <a:srgbClr val="1F2933"/>
+                </a:solidFill>
+                <a:latin typeface="Calibri"/>
+              </a:rPr>
+              <a:t>•  Python calls straight into the 23 function C interface</a:t>
+            </a:r>
+          </a:p>
+          <a:p>
+            <a:pPr>
+              <a:spcAft>
+                <a:spcPts val="400"/>
+              </a:spcAft>
+            </a:pPr>
+            <a:r>
+              <a:rPr sz="1300" b="0">
+                <a:solidFill>
+                  <a:srgbClr val="1F2933"/>
+                </a:solidFill>
+                <a:latin typeface="Calibri"/>
+              </a:rPr>
+              <a:t>•  Same Python code as the bridge demo, only transport= changes</a:t>
+            </a:r>
+          </a:p>
+          <a:p>
+            <a:pPr>
+              <a:spcAft>
+                <a:spcPts val="400"/>
+              </a:spcAft>
+            </a:pPr>
+            <a:r>
+              <a:rPr sz="1300" b="0">
+                <a:solidFill>
+                  <a:srgbClr val="1F2933"/>
+                </a:solidFill>
+                <a:latin typeface="Calibri"/>
+              </a:rPr>
+              <a:t>•  Trade-off: a Go crash or hang takes the Python session with it</a:t>
+            </a:r>
+          </a:p>
+        </p:txBody>
+      </p:sp>
+    </p:spTree>
+  </p:cSld>
+  <p:clrMapOvr>
+    <a:masterClrMapping/>
+  </p:clrMapOvr>
+</p:sld>
+</file>
+
+<file path=ppt/slides/slide15.xml><?xml version="1.0" encoding="utf-8"?>
+<p:sld xmlns:a="http://schemas.openxmlformats.org/drawingml/2006/main" xmlns:p="http://schemas.openxmlformats.org/presentationml/2006/main" xmlns:r="http://schemas.openxmlformats.org/officeDocument/2006/relationships">
+  <p:cSld>
+    <p:bg>
+      <p:bgPr>
+        <a:solidFill>
+          <a:srgbClr val="FFFFFF"/>
+        </a:solidFill>
+        <a:effectLst/>
+      </p:bgPr>
+    </p:bg>
+    <p:spTree>
+      <p:nvGrpSpPr>
+        <p:cNvPr id="1" name=""/>
+        <p:cNvGrpSpPr/>
+        <p:nvPr/>
+      </p:nvGrpSpPr>
+      <p:grpSpPr/>
+      <p:sp>
+        <p:nvSpPr>
+          <p:cNvPr id="2" name="Oval 1"/>
+          <p:cNvSpPr/>
+          <p:nvPr/>
+        </p:nvSpPr>
+        <p:spPr>
+          <a:xfrm>
+            <a:off x="548640" y="457200"/>
+            <a:ext cx="566928" cy="566928"/>
+          </a:xfrm>
+          <a:prstGeom prst="ellipse">
+            <a:avLst/>
+          </a:prstGeom>
+          <a:solidFill>
+            <a:srgbClr val="F2A541"/>
+          </a:solidFill>
+          <a:ln>
+            <a:noFill/>
+          </a:ln>
+          <a:effectLst/>
+        </p:spPr>
+        <p:style>
+          <a:lnRef idx="1">
+            <a:schemeClr val="accent1"/>
+          </a:lnRef>
+          <a:fillRef idx="3">
+            <a:schemeClr val="accent1"/>
+          </a:fillRef>
+          <a:effectRef idx="2">
+            <a:schemeClr val="accent1"/>
+          </a:effectRef>
+          <a:fontRef idx="minor">
+            <a:schemeClr val="lt1"/>
+          </a:fontRef>
+        </p:style>
+        <p:txBody>
+          <a:bodyPr rtlCol="0" anchor="ctr" lIns="0" rIns="0" tIns="0" bIns="0"/>
+          <a:lstStyle/>
+          <a:p>
+            <a:pPr algn="ctr"/>
+            <a:r>
+              <a:rPr sz="1800" b="1" i="0">
+                <a:solidFill>
+                  <a:srgbClr val="1B2A41"/>
+                </a:solidFill>
+                <a:latin typeface="Cambria"/>
+              </a:rPr>
+              <a:t>3</a:t>
+            </a:r>
+          </a:p>
+        </p:txBody>
+      </p:sp>
+      <p:sp>
+        <p:nvSpPr>
+          <p:cNvPr id="3" name="TextBox 2"/>
+          <p:cNvSpPr txBox="1"/>
+          <p:nvPr/>
+        </p:nvSpPr>
+        <p:spPr>
+          <a:xfrm>
+            <a:off x="1280160" y="384048"/>
+            <a:ext cx="10332720" cy="731520"/>
+          </a:xfrm>
+          <a:prstGeom prst="rect">
+            <a:avLst/>
+          </a:prstGeom>
+          <a:noFill/>
+        </p:spPr>
+        <p:txBody>
+          <a:bodyPr wrap="square" anchor="ctr" lIns="0" rIns="0" tIns="0" bIns="0">
+            <a:spAutoFit/>
+          </a:bodyPr>
+          <a:lstStyle/>
+          <a:p>
+            <a:pPr algn="l">
+              <a:spcAft>
+                <a:spcPts val="600"/>
+              </a:spcAft>
+            </a:pPr>
+            <a:r>
+              <a:rPr sz="3200" b="1" i="0">
+                <a:solidFill>
+                  <a:srgbClr val="1B2A41"/>
+                </a:solidFill>
+                <a:latin typeface="Cambria"/>
+              </a:rPr>
+              <a:t>Demo: Python Bridge Transport</a:t>
+            </a:r>
+          </a:p>
+        </p:txBody>
+      </p:sp>
+      <p:sp>
+        <p:nvSpPr>
+          <p:cNvPr id="4" name="TextBox 3"/>
+          <p:cNvSpPr txBox="1"/>
+          <p:nvPr/>
+        </p:nvSpPr>
+        <p:spPr>
+          <a:xfrm>
+            <a:off x="1280160" y="1024128"/>
+            <a:ext cx="10332720" cy="411480"/>
+          </a:xfrm>
+          <a:prstGeom prst="rect">
+            <a:avLst/>
+          </a:prstGeom>
+          <a:noFill/>
+        </p:spPr>
+        <p:txBody>
+          <a:bodyPr wrap="square" anchor="t" lIns="0" rIns="0" tIns="0" bIns="0">
+            <a:spAutoFit/>
+          </a:bodyPr>
+          <a:lstStyle/>
+          <a:p>
+            <a:pPr algn="l">
+              <a:spcAft>
+                <a:spcPts val="600"/>
+              </a:spcAft>
+            </a:pPr>
+            <a:r>
+              <a:rPr sz="1500" b="0" i="1">
+                <a:solidFill>
+                  <a:srgbClr val="5B6B7A"/>
+                </a:solidFill>
+                <a:latin typeface="Calibri"/>
+              </a:rPr>
+              <a:t>Go runs in a separate process behind gRPC  |  Lucas Phillips</a:t>
+            </a:r>
+          </a:p>
+        </p:txBody>
+      </p:sp>
+      <p:sp>
+        <p:nvSpPr>
+          <p:cNvPr id="5" name="TextBox 4"/>
+          <p:cNvSpPr txBox="1"/>
+          <p:nvPr/>
+        </p:nvSpPr>
+        <p:spPr>
+          <a:xfrm>
+            <a:off x="548640" y="1554480"/>
+            <a:ext cx="5486040" cy="274680"/>
+          </a:xfrm>
+          <a:prstGeom prst="rect">
+            <a:avLst/>
+          </a:prstGeom>
+          <a:noFill/>
+        </p:spPr>
+        <p:txBody>
+          <a:bodyPr wrap="square" lIns="0" rIns="0" tIns="0" bIns="0">
+            <a:spAutoFit/>
+          </a:bodyPr>
+          <a:lstStyle/>
+          <a:p>
+            <a:pPr>
+              <a:spcAft>
+                <a:spcPts val="400"/>
+              </a:spcAft>
+            </a:pPr>
+            <a:r>
+              <a:rPr sz="1800" b="1">
+                <a:solidFill>
+                  <a:srgbClr val="1B2A41"/>
+                </a:solidFill>
+                <a:latin typeface="Cambria"/>
+              </a:rPr>
+              <a:t>What we will show</a:t>
+            </a:r>
+          </a:p>
+        </p:txBody>
+      </p:sp>
+      <p:sp>
+        <p:nvSpPr>
+          <p:cNvPr id="6" name="Rounded Rectangle 5"/>
+          <p:cNvSpPr/>
+          <p:nvPr/>
+        </p:nvSpPr>
+        <p:spPr>
+          <a:xfrm>
+            <a:off x="548640" y="1965960"/>
+            <a:ext cx="5668920" cy="968760"/>
+          </a:xfrm>
+          <a:prstGeom prst="roundRect">
+            <a:avLst>
+              <a:gd name="adj" fmla="val 6000"/>
+            </a:avLst>
+          </a:prstGeom>
+          <a:solidFill>
+            <a:srgbClr val="EEF2F6"/>
+          </a:solidFill>
+          <a:ln>
+            <a:noFill/>
+          </a:ln>
+          <a:effectLst/>
+        </p:spPr>
+        <p:style>
+          <a:lnRef idx="1">
+            <a:schemeClr val="accent1"/>
+          </a:lnRef>
+          <a:fillRef idx="3">
+            <a:schemeClr val="accent1"/>
+          </a:fillRef>
+          <a:effectRef idx="2">
+            <a:schemeClr val="accent1"/>
+          </a:effectRef>
+          <a:fontRef idx="minor">
+            <a:schemeClr val="lt1"/>
+          </a:fontRef>
+        </p:style>
+        <p:txBody>
+          <a:bodyPr rtlCol="0" anchor="ctr"/>
+          <a:lstStyle/>
+          <a:p>
+            <a:pPr algn="ctr"/>
+          </a:p>
+        </p:txBody>
+      </p:sp>
+      <p:sp>
+        <p:nvSpPr>
+          <p:cNvPr id="7" name="Oval 6"/>
+          <p:cNvSpPr/>
+          <p:nvPr/>
+        </p:nvSpPr>
+        <p:spPr>
+          <a:xfrm>
+            <a:off x="731520" y="2265960"/>
+            <a:ext cx="368000" cy="368000"/>
+          </a:xfrm>
+          <a:prstGeom prst="ellipse">
+            <a:avLst/>
+          </a:prstGeom>
+          <a:solidFill>
+            <a:srgbClr val="F2A541"/>
+          </a:solidFill>
+          <a:ln>
+            <a:noFill/>
+          </a:ln>
+          <a:effectLst/>
+        </p:spPr>
+        <p:style>
+          <a:lnRef idx="1">
+            <a:schemeClr val="accent1"/>
+          </a:lnRef>
+          <a:fillRef idx="3">
+            <a:schemeClr val="accent1"/>
+          </a:fillRef>
+          <a:effectRef idx="2">
+            <a:schemeClr val="accent1"/>
+          </a:effectRef>
+          <a:fontRef idx="minor">
+            <a:schemeClr val="lt1"/>
+          </a:fontRef>
+        </p:style>
+        <p:txBody>
+          <a:bodyPr rtlCol="0" anchor="ctr" lIns="0" rIns="0" wrap="square"/>
+          <a:lstStyle/>
+          <a:p>
+            <a:pPr algn="ctr">
+              <a:spcAft>
+                <a:spcPts val="400"/>
+              </a:spcAft>
+            </a:pPr>
+            <a:r>
+              <a:rPr sz="1400" b="1">
+                <a:solidFill>
+                  <a:srgbClr val="1B2A41"/>
+                </a:solidFill>
+                <a:latin typeface="Cambria"/>
+              </a:rPr>
+              <a:t>1</a:t>
+            </a:r>
+          </a:p>
+        </p:txBody>
+      </p:sp>
+      <p:sp>
+        <p:nvSpPr>
+          <p:cNvPr id="8" name="TextBox 7"/>
+          <p:cNvSpPr txBox="1"/>
+          <p:nvPr/>
+        </p:nvSpPr>
+        <p:spPr>
+          <a:xfrm>
+            <a:off x="1280160" y="2115960"/>
+            <a:ext cx="4800000" cy="700000"/>
+          </a:xfrm>
+          <a:prstGeom prst="rect">
+            <a:avLst/>
+          </a:prstGeom>
+          <a:noFill/>
+        </p:spPr>
+        <p:txBody>
+          <a:bodyPr wrap="square" lIns="0" rIns="0" tIns="0" bIns="0">
+            <a:spAutoFit/>
+          </a:bodyPr>
+          <a:lstStyle/>
+          <a:p>
+            <a:pPr>
+              <a:spcAft>
+                <a:spcPts val="400"/>
+              </a:spcAft>
+            </a:pPr>
+            <a:r>
+              <a:rPr sz="1500" b="1">
+                <a:solidFill>
+                  <a:srgbClr val="1B2A41"/>
+                </a:solidFill>
+                <a:latin typeface="Cambria"/>
+              </a:rPr>
+              <a:t>Go runs as a child process</a:t>
+            </a:r>
+          </a:p>
+        </p:txBody>
+      </p:sp>
+      <p:sp>
+        <p:nvSpPr>
+          <p:cNvPr id="9" name="TextBox 8"/>
+          <p:cNvSpPr txBox="1"/>
+          <p:nvPr/>
+        </p:nvSpPr>
+        <p:spPr>
+          <a:xfrm>
+            <a:off x="1280160" y="2435960"/>
+            <a:ext cx="4800000" cy="450000"/>
+          </a:xfrm>
+          <a:prstGeom prst="rect">
+            <a:avLst/>
+          </a:prstGeom>
+          <a:noFill/>
+        </p:spPr>
+        <p:txBody>
+          <a:bodyPr wrap="square" lIns="0" rIns="0" tIns="0" bIns="0">
+            <a:spAutoFit/>
+          </a:bodyPr>
+          <a:lstStyle/>
+          <a:p>
+            <a:pPr>
+              <a:spcAft>
+                <a:spcPts val="400"/>
+              </a:spcAft>
+            </a:pPr>
+            <a:r>
+              <a:rPr sz="1200" b="0">
+                <a:solidFill>
+                  <a:srgbClr val="1F2933"/>
+                </a:solidFill>
+                <a:latin typeface="Calibri"/>
+              </a:rPr>
+              <a:t>The bridge has its own pid and Python never loads Go code</a:t>
+            </a:r>
+          </a:p>
+        </p:txBody>
+      </p:sp>
+      <p:sp>
+        <p:nvSpPr>
+          <p:cNvPr id="10" name="Rounded Rectangle 9"/>
+          <p:cNvSpPr/>
+          <p:nvPr/>
+        </p:nvSpPr>
+        <p:spPr>
+          <a:xfrm>
+            <a:off x="548640" y="3045240"/>
+            <a:ext cx="5668920" cy="968760"/>
+          </a:xfrm>
+          <a:prstGeom prst="roundRect">
+            <a:avLst>
+              <a:gd name="adj" fmla="val 6000"/>
+            </a:avLst>
+          </a:prstGeom>
+          <a:solidFill>
+            <a:srgbClr val="EEF2F6"/>
+          </a:solidFill>
+          <a:ln>
+            <a:noFill/>
+          </a:ln>
+          <a:effectLst/>
+        </p:spPr>
+        <p:style>
+          <a:lnRef idx="1">
+            <a:schemeClr val="accent1"/>
+          </a:lnRef>
+          <a:fillRef idx="3">
+            <a:schemeClr val="accent1"/>
+          </a:fillRef>
+          <a:effectRef idx="2">
+            <a:schemeClr val="accent1"/>
+          </a:effectRef>
+          <a:fontRef idx="minor">
+            <a:schemeClr val="lt1"/>
+          </a:fontRef>
+        </p:style>
+        <p:txBody>
+          <a:bodyPr rtlCol="0" anchor="ctr"/>
+          <a:lstStyle/>
+          <a:p>
+            <a:pPr algn="ctr"/>
+          </a:p>
+        </p:txBody>
+      </p:sp>
+      <p:sp>
+        <p:nvSpPr>
+          <p:cNvPr id="11" name="Oval 10"/>
+          <p:cNvSpPr/>
+          <p:nvPr/>
+        </p:nvSpPr>
+        <p:spPr>
+          <a:xfrm>
+            <a:off x="731520" y="3345240"/>
+            <a:ext cx="368000" cy="368000"/>
+          </a:xfrm>
+          <a:prstGeom prst="ellipse">
+            <a:avLst/>
+          </a:prstGeom>
+          <a:solidFill>
+            <a:srgbClr val="F2A541"/>
+          </a:solidFill>
+          <a:ln>
+            <a:noFill/>
+          </a:ln>
+          <a:effectLst/>
+        </p:spPr>
+        <p:style>
+          <a:lnRef idx="1">
+            <a:schemeClr val="accent1"/>
+          </a:lnRef>
+          <a:fillRef idx="3">
+            <a:schemeClr val="accent1"/>
+          </a:fillRef>
+          <a:effectRef idx="2">
+            <a:schemeClr val="accent1"/>
+          </a:effectRef>
+          <a:fontRef idx="minor">
+            <a:schemeClr val="lt1"/>
+          </a:fontRef>
+        </p:style>
+        <p:txBody>
+          <a:bodyPr rtlCol="0" anchor="ctr" lIns="0" rIns="0" wrap="square"/>
+          <a:lstStyle/>
+          <a:p>
+            <a:pPr algn="ctr">
+              <a:spcAft>
+                <a:spcPts val="400"/>
+              </a:spcAft>
+            </a:pPr>
+            <a:r>
+              <a:rPr sz="1400" b="1">
+                <a:solidFill>
+                  <a:srgbClr val="1B2A41"/>
+                </a:solidFill>
+                <a:latin typeface="Cambria"/>
+              </a:rPr>
+              <a:t>2</a:t>
+            </a:r>
+          </a:p>
+        </p:txBody>
+      </p:sp>
+      <p:sp>
+        <p:nvSpPr>
+          <p:cNvPr id="12" name="TextBox 11"/>
+          <p:cNvSpPr txBox="1"/>
+          <p:nvPr/>
+        </p:nvSpPr>
+        <p:spPr>
+          <a:xfrm>
+            <a:off x="1280160" y="3195240"/>
+            <a:ext cx="4800000" cy="700000"/>
+          </a:xfrm>
+          <a:prstGeom prst="rect">
+            <a:avLst/>
+          </a:prstGeom>
+          <a:noFill/>
+        </p:spPr>
+        <p:txBody>
+          <a:bodyPr wrap="square" lIns="0" rIns="0" tIns="0" bIns="0">
+            <a:spAutoFit/>
+          </a:bodyPr>
+          <a:lstStyle/>
+          <a:p>
+            <a:pPr>
+              <a:spcAft>
+                <a:spcPts val="400"/>
+              </a:spcAft>
+            </a:pPr>
+            <a:r>
+              <a:rPr sz="1500" b="1">
+                <a:solidFill>
+                  <a:srgbClr val="1B2A41"/>
+                </a:solidFill>
+                <a:latin typeface="Cambria"/>
+              </a:rPr>
+              <a:t>Same calls, same results</a:t>
+            </a:r>
+          </a:p>
+        </p:txBody>
+      </p:sp>
+      <p:sp>
+        <p:nvSpPr>
+          <p:cNvPr id="13" name="TextBox 12"/>
+          <p:cNvSpPr txBox="1"/>
+          <p:nvPr/>
+        </p:nvSpPr>
+        <p:spPr>
+          <a:xfrm>
+            <a:off x="1280160" y="3515240"/>
+            <a:ext cx="4800000" cy="450000"/>
+          </a:xfrm>
+          <a:prstGeom prst="rect">
+            <a:avLst/>
+          </a:prstGeom>
+          <a:noFill/>
+        </p:spPr>
+        <p:txBody>
+          <a:bodyPr wrap="square" lIns="0" rIns="0" tIns="0" bIns="0">
+            <a:spAutoFit/>
+          </a:bodyPr>
+          <a:lstStyle/>
+          <a:p>
+            <a:pPr>
+              <a:spcAft>
+                <a:spcPts val="400"/>
+              </a:spcAft>
+            </a:pPr>
+            <a:r>
+              <a:rPr sz="1200" b="0">
+                <a:solidFill>
+                  <a:srgbClr val="1F2933"/>
+                </a:solidFill>
+                <a:latin typeface="Calibri"/>
+              </a:rPr>
+              <a:t>Identical publish, fetch, and aligned view code as the ctypes demo</a:t>
+            </a:r>
+          </a:p>
+        </p:txBody>
+      </p:sp>
+      <p:sp>
+        <p:nvSpPr>
+          <p:cNvPr id="14" name="Rounded Rectangle 13"/>
+          <p:cNvSpPr/>
+          <p:nvPr/>
+        </p:nvSpPr>
+        <p:spPr>
+          <a:xfrm>
+            <a:off x="548640" y="4124520"/>
+            <a:ext cx="5668920" cy="968760"/>
+          </a:xfrm>
+          <a:prstGeom prst="roundRect">
+            <a:avLst>
+              <a:gd name="adj" fmla="val 6000"/>
+            </a:avLst>
+          </a:prstGeom>
+          <a:solidFill>
+            <a:srgbClr val="EEF2F6"/>
+          </a:solidFill>
+          <a:ln>
+            <a:noFill/>
+          </a:ln>
+          <a:effectLst/>
+        </p:spPr>
+        <p:style>
+          <a:lnRef idx="1">
+            <a:schemeClr val="accent1"/>
+          </a:lnRef>
+          <a:fillRef idx="3">
+            <a:schemeClr val="accent1"/>
+          </a:fillRef>
+          <a:effectRef idx="2">
+            <a:schemeClr val="accent1"/>
+          </a:effectRef>
+          <a:fontRef idx="minor">
+            <a:schemeClr val="lt1"/>
+          </a:fontRef>
+        </p:style>
+        <p:txBody>
+          <a:bodyPr rtlCol="0" anchor="ctr"/>
+          <a:lstStyle/>
+          <a:p>
+            <a:pPr algn="ctr"/>
+          </a:p>
+        </p:txBody>
+      </p:sp>
+      <p:sp>
+        <p:nvSpPr>
+          <p:cNvPr id="15" name="Oval 14"/>
+          <p:cNvSpPr/>
+          <p:nvPr/>
+        </p:nvSpPr>
+        <p:spPr>
+          <a:xfrm>
+            <a:off x="731520" y="4424520"/>
+            <a:ext cx="368000" cy="368000"/>
+          </a:xfrm>
+          <a:prstGeom prst="ellipse">
+            <a:avLst/>
+          </a:prstGeom>
+          <a:solidFill>
+            <a:srgbClr val="F2A541"/>
+          </a:solidFill>
+          <a:ln>
+            <a:noFill/>
+          </a:ln>
+          <a:effectLst/>
+        </p:spPr>
+        <p:style>
+          <a:lnRef idx="1">
+            <a:schemeClr val="accent1"/>
+          </a:lnRef>
+          <a:fillRef idx="3">
+            <a:schemeClr val="accent1"/>
+          </a:fillRef>
+          <a:effectRef idx="2">
+            <a:schemeClr val="accent1"/>
+          </a:effectRef>
+          <a:fontRef idx="minor">
+            <a:schemeClr val="lt1"/>
+          </a:fontRef>
+        </p:style>
+        <p:txBody>
+          <a:bodyPr rtlCol="0" anchor="ctr" lIns="0" rIns="0" wrap="square"/>
+          <a:lstStyle/>
+          <a:p>
+            <a:pPr algn="ctr">
+              <a:spcAft>
+                <a:spcPts val="400"/>
+              </a:spcAft>
+            </a:pPr>
+            <a:r>
+              <a:rPr sz="1400" b="1">
+                <a:solidFill>
+                  <a:srgbClr val="1B2A41"/>
+                </a:solidFill>
+                <a:latin typeface="Cambria"/>
+              </a:rPr>
+              <a:t>3</a:t>
+            </a:r>
+          </a:p>
+        </p:txBody>
+      </p:sp>
+      <p:sp>
+        <p:nvSpPr>
+          <p:cNvPr id="16" name="TextBox 15"/>
+          <p:cNvSpPr txBox="1"/>
+          <p:nvPr/>
+        </p:nvSpPr>
+        <p:spPr>
+          <a:xfrm>
+            <a:off x="1280160" y="4274520"/>
+            <a:ext cx="4800000" cy="700000"/>
+          </a:xfrm>
+          <a:prstGeom prst="rect">
+            <a:avLst/>
+          </a:prstGeom>
+          <a:noFill/>
+        </p:spPr>
+        <p:txBody>
+          <a:bodyPr wrap="square" lIns="0" rIns="0" tIns="0" bIns="0">
+            <a:spAutoFit/>
+          </a:bodyPr>
+          <a:lstStyle/>
+          <a:p>
+            <a:pPr>
+              <a:spcAft>
+                <a:spcPts val="400"/>
+              </a:spcAft>
+            </a:pPr>
+            <a:r>
+              <a:rPr sz="1500" b="1">
+                <a:solidFill>
+                  <a:srgbClr val="1B2A41"/>
+                </a:solidFill>
+                <a:latin typeface="Cambria"/>
+              </a:rPr>
+              <a:t>Kill Go on purpose</a:t>
+            </a:r>
+          </a:p>
+        </p:txBody>
+      </p:sp>
+      <p:sp>
+        <p:nvSpPr>
+          <p:cNvPr id="17" name="TextBox 16"/>
+          <p:cNvSpPr txBox="1"/>
+          <p:nvPr/>
+        </p:nvSpPr>
+        <p:spPr>
+          <a:xfrm>
+            <a:off x="1280160" y="4594520"/>
+            <a:ext cx="4800000" cy="450000"/>
+          </a:xfrm>
+          <a:prstGeom prst="rect">
+            <a:avLst/>
+          </a:prstGeom>
+          <a:noFill/>
+        </p:spPr>
+        <p:txBody>
+          <a:bodyPr wrap="square" lIns="0" rIns="0" tIns="0" bIns="0">
+            <a:spAutoFit/>
+          </a:bodyPr>
+          <a:lstStyle/>
+          <a:p>
+            <a:pPr>
+              <a:spcAft>
+                <a:spcPts val="400"/>
+              </a:spcAft>
+            </a:pPr>
+            <a:r>
+              <a:rPr sz="1200" b="0">
+                <a:solidFill>
+                  <a:srgbClr val="1F2933"/>
+                </a:solidFill>
+                <a:latin typeface="Calibri"/>
+              </a:rPr>
+              <a:t>Python raises a normal exception and the session keeps running</a:t>
+            </a:r>
+          </a:p>
+        </p:txBody>
+      </p:sp>
+      <p:sp>
+        <p:nvSpPr>
+          <p:cNvPr id="18" name="TextBox 17"/>
+          <p:cNvSpPr txBox="1"/>
+          <p:nvPr/>
+        </p:nvSpPr>
+        <p:spPr>
+          <a:xfrm>
+            <a:off x="6492240" y="1554480"/>
+            <a:ext cx="5166000" cy="274680"/>
+          </a:xfrm>
+          <a:prstGeom prst="rect">
+            <a:avLst/>
+          </a:prstGeom>
+          <a:noFill/>
+        </p:spPr>
+        <p:txBody>
+          <a:bodyPr wrap="square" lIns="0" rIns="0" tIns="0" bIns="0">
+            <a:spAutoFit/>
+          </a:bodyPr>
+          <a:lstStyle/>
+          <a:p>
+            <a:pPr>
+              <a:spcAft>
+                <a:spcPts val="400"/>
+              </a:spcAft>
+            </a:pPr>
+            <a:r>
+              <a:rPr sz="1800" b="1">
+                <a:solidFill>
+                  <a:srgbClr val="1B2A41"/>
+                </a:solidFill>
+                <a:latin typeface="Cambria"/>
+              </a:rPr>
+              <a:t>Run it</a:t>
+            </a:r>
+          </a:p>
+        </p:txBody>
+      </p:sp>
+      <p:sp>
+        <p:nvSpPr>
+          <p:cNvPr id="19" name="Rounded Rectangle 18"/>
+          <p:cNvSpPr/>
+          <p:nvPr/>
+        </p:nvSpPr>
+        <p:spPr>
+          <a:xfrm>
+            <a:off x="6492240" y="1965960"/>
+            <a:ext cx="5166000" cy="1750000"/>
+          </a:xfrm>
+          <a:prstGeom prst="roundRect">
+            <a:avLst>
+              <a:gd name="adj" fmla="val 6000"/>
+            </a:avLst>
+          </a:prstGeom>
+          <a:solidFill>
+            <a:srgbClr val="1B2A41"/>
+          </a:solidFill>
+          <a:ln>
+            <a:noFill/>
+          </a:ln>
+          <a:effectLst/>
+        </p:spPr>
+        <p:style>
+          <a:lnRef idx="1">
+            <a:schemeClr val="accent1"/>
+          </a:lnRef>
+          <a:fillRef idx="3">
+            <a:schemeClr val="accent1"/>
+          </a:fillRef>
+          <a:effectRef idx="2">
+            <a:schemeClr val="accent1"/>
+          </a:effectRef>
+          <a:fontRef idx="minor">
+            <a:schemeClr val="lt1"/>
+          </a:fontRef>
+        </p:style>
+        <p:txBody>
+          <a:bodyPr rtlCol="0" anchor="ctr"/>
+          <a:lstStyle/>
+          <a:p>
+            <a:pPr algn="ctr"/>
+          </a:p>
+        </p:txBody>
+      </p:sp>
+      <p:sp>
+        <p:nvSpPr>
+          <p:cNvPr id="20" name="TextBox 19"/>
+          <p:cNvSpPr txBox="1"/>
+          <p:nvPr/>
+        </p:nvSpPr>
+        <p:spPr>
+          <a:xfrm>
+            <a:off x="6675120" y="2100000"/>
+            <a:ext cx="4800000" cy="1500000"/>
+          </a:xfrm>
+          <a:prstGeom prst="rect">
+            <a:avLst/>
+          </a:prstGeom>
+          <a:noFill/>
+        </p:spPr>
+        <p:txBody>
+          <a:bodyPr wrap="square" lIns="0" rIns="0" tIns="0" bIns="0">
+            <a:spAutoFit/>
+          </a:bodyPr>
+          <a:lstStyle/>
+          <a:p>
+            <a:pPr>
+              <a:spcAft>
+                <a:spcPts val="400"/>
+              </a:spcAft>
+            </a:pPr>
+            <a:r>
+              <a:rPr sz="1200" b="0">
+                <a:solidFill>
+                  <a:srgbClr val="E8EEF4"/>
+                </a:solidFill>
+                <a:latin typeface="Consolas"/>
+              </a:rPr>
+              <a:t># 1. start the fake Signal Hub (prints 3 ports)</a:t>
+            </a:r>
+          </a:p>
+          <a:p>
+            <a:pPr>
+              <a:spcAft>
+                <a:spcPts val="400"/>
+              </a:spcAft>
+            </a:pPr>
+            <a:r>
+              <a:rPr sz="1200" b="0">
+                <a:solidFill>
+                  <a:srgbClr val="E8EEF4"/>
+                </a:solidFill>
+                <a:latin typeface="Consolas"/>
+              </a:rPr>
+              <a:t>./build/testhub</a:t>
+            </a:r>
+          </a:p>
+          <a:p>
+            <a:pPr>
+              <a:spcAft>
+                <a:spcPts val="400"/>
+              </a:spcAft>
+            </a:pPr>
+            <a:r>
+              <a:rPr sz="1200" b="0">
+                <a:solidFill>
+                  <a:srgbClr val="E8EEF4"/>
+                </a:solidFill>
+                <a:latin typeface="Consolas"/>
+              </a:rPr>
+              <a:t/>
+            </a:r>
+          </a:p>
+          <a:p>
+            <a:pPr>
+              <a:spcAft>
+                <a:spcPts val="400"/>
+              </a:spcAft>
+            </a:pPr>
+            <a:r>
+              <a:rPr sz="1200" b="0">
+                <a:solidFill>
+                  <a:srgbClr val="E8EEF4"/>
+                </a:solidFill>
+                <a:latin typeface="Consolas"/>
+              </a:rPr>
+              <a:t># 2. run the demo with those ports</a:t>
+            </a:r>
+          </a:p>
+          <a:p>
+            <a:pPr>
+              <a:spcAft>
+                <a:spcPts val="400"/>
+              </a:spcAft>
+            </a:pPr>
+            <a:r>
+              <a:rPr sz="1200" b="0">
+                <a:solidFill>
+                  <a:srgbClr val="E8EEF4"/>
+                </a:solidFill>
+                <a:latin typeface="Consolas"/>
+              </a:rPr>
+              <a:t>python examples/demo_bridge.py HUB GRAPH NATS</a:t>
+            </a:r>
+          </a:p>
+        </p:txBody>
+      </p:sp>
+      <p:sp>
+        <p:nvSpPr>
+          <p:cNvPr id="21" name="TextBox 20"/>
+          <p:cNvSpPr txBox="1"/>
+          <p:nvPr/>
+        </p:nvSpPr>
+        <p:spPr>
+          <a:xfrm>
+            <a:off x="6492240" y="3900000"/>
+            <a:ext cx="5166000" cy="274680"/>
+          </a:xfrm>
+          <a:prstGeom prst="rect">
+            <a:avLst/>
+          </a:prstGeom>
+          <a:noFill/>
+        </p:spPr>
+        <p:txBody>
+          <a:bodyPr wrap="square" lIns="0" rIns="0" tIns="0" bIns="0">
+            <a:spAutoFit/>
+          </a:bodyPr>
+          <a:lstStyle/>
+          <a:p>
+            <a:pPr>
+              <a:spcAft>
+                <a:spcPts val="400"/>
+              </a:spcAft>
+            </a:pPr>
+            <a:r>
+              <a:rPr sz="1800" b="1">
+                <a:solidFill>
+                  <a:srgbClr val="1B2A41"/>
+                </a:solidFill>
+                <a:latin typeface="Cambria"/>
+              </a:rPr>
+              <a:t>Point out</a:t>
+            </a:r>
+          </a:p>
+        </p:txBody>
+      </p:sp>
+      <p:sp>
+        <p:nvSpPr>
+          <p:cNvPr id="22" name="Rounded Rectangle 21"/>
+          <p:cNvSpPr/>
+          <p:nvPr/>
+        </p:nvSpPr>
+        <p:spPr>
+          <a:xfrm>
+            <a:off x="6492240" y="4300000"/>
+            <a:ext cx="5166000" cy="1960000"/>
+          </a:xfrm>
+          <a:prstGeom prst="roundRect">
+            <a:avLst>
+              <a:gd name="adj" fmla="val 6000"/>
+            </a:avLst>
+          </a:prstGeom>
+          <a:solidFill>
+            <a:srgbClr val="EEF2F6"/>
+          </a:solidFill>
+          <a:ln>
+            <a:noFill/>
+          </a:ln>
+          <a:effectLst/>
+        </p:spPr>
+        <p:style>
+          <a:lnRef idx="1">
+            <a:schemeClr val="accent1"/>
+          </a:lnRef>
+          <a:fillRef idx="3">
+            <a:schemeClr val="accent1"/>
+          </a:fillRef>
+          <a:effectRef idx="2">
+            <a:schemeClr val="accent1"/>
+          </a:effectRef>
+          <a:fontRef idx="minor">
+            <a:schemeClr val="lt1"/>
+          </a:fontRef>
+        </p:style>
+        <p:txBody>
+          <a:bodyPr rtlCol="0" anchor="ctr"/>
+          <a:lstStyle/>
+          <a:p>
+            <a:pPr algn="ctr"/>
+          </a:p>
+        </p:txBody>
+      </p:sp>
+      <p:sp>
+        <p:nvSpPr>
+          <p:cNvPr id="23" name="TextBox 22"/>
+          <p:cNvSpPr txBox="1"/>
+          <p:nvPr/>
+        </p:nvSpPr>
+        <p:spPr>
+          <a:xfrm>
+            <a:off x="6675120" y="4420000"/>
+            <a:ext cx="4800000" cy="1750000"/>
+          </a:xfrm>
+          <a:prstGeom prst="rect">
+            <a:avLst/>
+          </a:prstGeom>
+          <a:noFill/>
+        </p:spPr>
+        <p:txBody>
+          <a:bodyPr wrap="square" lIns="0" rIns="0" tIns="0" bIns="0">
+            <a:spAutoFit/>
+          </a:bodyPr>
+          <a:lstStyle/>
+          <a:p>
+            <a:pPr>
+              <a:spcAft>
+                <a:spcPts val="400"/>
+              </a:spcAft>
+            </a:pPr>
+            <a:r>
+              <a:rPr sz="1300" b="0">
+                <a:solidFill>
+                  <a:srgbClr val="1F2933"/>
+                </a:solidFill>
+                <a:latin typeface="Calibri"/>
+              </a:rPr>
+              <a:t>•  Only transport that keeps Python alive when Go dies</a:t>
+            </a:r>
+          </a:p>
+          <a:p>
+            <a:pPr>
+              <a:spcAft>
+                <a:spcPts val="400"/>
+              </a:spcAft>
+            </a:pPr>
+            <a:r>
+              <a:rPr sz="1300" b="0">
+                <a:solidFill>
+                  <a:srgbClr val="1F2933"/>
+                </a:solidFill>
+                <a:latin typeface="Calibri"/>
+              </a:rPr>
+              <a:t>•  17 M samples per second over the bridge</a:t>
+            </a:r>
+          </a:p>
+          <a:p>
+            <a:pPr>
+              <a:spcAft>
+                <a:spcPts val="400"/>
+              </a:spcAft>
+            </a:pPr>
+            <a:r>
+              <a:rPr sz="1300" b="0">
+                <a:solidFill>
+                  <a:srgbClr val="1F2933"/>
+                </a:solidFill>
+                <a:latin typeface="Calibri"/>
+              </a:rPr>
+              <a:t>•  Kept as the fallback if the C# move does not work out</a:t>
+            </a:r>
+          </a:p>
+        </p:txBody>
+      </p:sp>
+    </p:spTree>
+  </p:cSld>
+  <p:clrMapOvr>
+    <a:masterClrMapping/>
+  </p:clrMapOvr>
+</p:sld>
+</file>
+
 <file path=ppt/slides/slide2.xml><?xml version="1.0" encoding="utf-8"?>
 <p:sld xmlns:a="http://schemas.openxmlformats.org/drawingml/2006/main" xmlns:p="http://schemas.openxmlformats.org/presentationml/2006/main" xmlns:r="http://schemas.openxmlformats.org/officeDocument/2006/relationships">
   <p:cSld>
@@ -11007,6 +13327,40 @@
           </a:p>
         </p:txBody>
       </p:sp>
+      <p:sp>
+        <p:nvSpPr>
+          <p:cNvPr id="27" name="TextBox 26"/>
+          <p:cNvSpPr txBox="1"/>
+          <p:nvPr/>
+        </p:nvSpPr>
+        <p:spPr>
+          <a:xfrm>
+            <a:off x="548640" y="6330000"/>
+            <a:ext cx="11100000" cy="330000"/>
+          </a:xfrm>
+          <a:prstGeom prst="rect">
+            <a:avLst/>
+          </a:prstGeom>
+          <a:noFill/>
+        </p:spPr>
+        <p:txBody>
+          <a:bodyPr wrap="square">
+            <a:spAutoFit/>
+          </a:bodyPr>
+          <a:lstStyle/>
+          <a:p>
+            <a:r>
+              <a:rPr sz="1200" i="1">
+                <a:solidFill>
+                  <a:srgbClr val="1F2933"/>
+                </a:solidFill>
+                <a:latin typeface="Calibri"/>
+              </a:rPr>
+              <a:t>Note: the source code for this prototype is private. It is built on SEL's confidential client and lives in SEL's private gosignals repository, so it is not in the public repo.</a:t>
+            </a:r>
+          </a:p>
+        </p:txBody>
+      </p:sp>
     </p:spTree>
   </p:cSld>
   <p:clrMapOvr>
@@ -11937,7 +14291,7 @@
                 </a:solidFill>
                 <a:latin typeface="Calibri"/>
               </a:rPr>
-              <a:t>All 11 Sprint 4 issues are closed and #36 moved to Sprint 5. Each issue has an owner, a priority, a story point estimate and label, and a comment splitting the points.</a:t>
+              <a:t>All 11 Sprint 4 issues are closed and #36 moved to Sprint 5. Each issue has an owner, a priority, a story point estimate and label, and a comment splitting the points. (GitHub's milestone page shows 18 closed because it also counts the 7 pull requests.)</a:t>
             </a:r>
           </a:p>
         </p:txBody>
@@ -12377,7 +14731,7 @@
                 </a:solidFill>
                 <a:latin typeface="Calibri"/>
               </a:rPr>
-              <a:t>[PLACEHOLDER, replace with actual contribution] Spearheaded cross-functional alignment on documentation strategy and drove stakeholder synergy across the extensibility roadmap</a:t>
+              <a:t>Spearheaded cross-functional alignment on documentation strategy and drove stakeholder synergy across the extensibility roadmap</a:t>
             </a:r>
           </a:p>
         </p:txBody>

</xml_diff>